<commit_message>
Align chapter 5, slides and speech with four-step purchase path
Co-Authored-By: Claude Opus 5.5 <noreply@anthropic.com>
Claude-Session: https://claude.ai/code/session_01CU6W6huYbDSXyzWhJKPgvt
</commit_message>
<xml_diff>
--- a/ppt/v4/制作1_封面目录分隔页_P2-P5_P14-P15.pptx
+++ b/ppt/v4/制作1_封面目录分隔页_P2-P5_P14-P15.pptx
@@ -117,13 +117,13 @@
   <p:extLst>
     <p:ext uri="{521415D9-36F7-43E2-AB2F-B90AF26B5E84}">
       <p14:sectionLst xmlns:p14="http://schemas.microsoft.com/office/powerpoint/2010/main">
-        <p14:section name="开场" id="{5a2961d5-efff-2609-3bb1-eb4922cde26e}">
+        <p14:section name="开场" id="{30a571b1-1f87-a54c-e5c6-4334db7f295f}">
           <p14:sldIdLst>
             <p14:sldId id="256"/>
             <p14:sldId id="257"/>
           </p14:sldIdLst>
         </p14:section>
-        <p14:section name="背景与问题" id="{60ac25ad-9574-4d00-1c28-ba1d80003bff}">
+        <p14:section name="背景与问题" id="{4c5b3b49-f2c7-7791-a8f9-93f122714c10}">
           <p14:sldIdLst>
             <p14:sldId id="258"/>
             <p14:sldId id="259"/>
@@ -132,13 +132,13 @@
             <p14:sldId id="262"/>
           </p14:sldIdLst>
         </p14:section>
-        <p14:section name="分隔页（插到方案、执行部分前）" id="{90c01f29-74d6-bf1b-d267-e0c8955f4402}">
+        <p14:section name="分隔页（插到方案、执行部分前）" id="{26f8b96f-0055-15c7-8bd0-f46272af90b9}">
           <p14:sldIdLst>
             <p14:sldId id="263"/>
             <p14:sldId id="264"/>
           </p14:sldIdLst>
         </p14:section>
-        <p14:section name="总结与封底" id="{3aac9ec0-fbfd-f02d-f1ab-954520f138e6}">
+        <p14:section name="总结与封底" id="{55a1a3d4-23f1-1ea8-1977-0ffc33d666c6}">
           <p14:sldIdLst>
             <p14:sldId id="265"/>
             <p14:sldId id="266"/>
@@ -1076,7 +1076,7 @@
           <a:p>
             <a:r>
               <a:rPr lang="en-US" dirty="0"/>
-              <a:t>【A｜约 30 秒】用自己的经历讲：我上周刷小红书看到一款新零食，第二天就去了学校门口的零食店，先买一小包；吃完第一件事是翻过来看配料表。这就是年轻人买零食的五步：种草、尝鲜、第一口、验证、复购。我们访谈的 15 个人里，10 个最近一次是在小红书被种草，9 个吃完会查配料或含糖量。而美枣王在每一步都掉队：线上没人种草，店里不显眼，枣像养生品，包装没回答健康问题，也没有再买的理由。</a:t>
+              <a:t>【A｜约 30 秒】用自己的经历讲：我上周刷小红书看到一款新零食，第二天就去了学校门口的零食店，先买一小包；吃完第一件事是翻过来看配料表。这就是年轻人买零食的四步：种草、尝鲜、验证、复购。我们访谈的 15 个人里，10 个最近一次是在小红书被种草，9 个吃完会查配料或含糖量。而美枣王在每一步都掉队：线上没人种草，店里不显眼，枣像养生品，包装没回答健康问题，也没有再买的理由。</a:t>
             </a:r>
             <a:endParaRPr lang="en-US" dirty="0"/>
           </a:p>
@@ -5322,7 +5322,7 @@
                   <a:schemeClr val="tx2"/>
                 </a:solidFill>
               </a:rPr>
-              <a:t>年轻人五步买零食，美枣王步步掉队</a:t>
+              <a:t>年轻人四步买零食，美枣王步步掉队</a:t>
             </a:r>
             <a:endParaRPr lang="en-US" sz="3000" dirty="0"/>
           </a:p>
@@ -5412,7 +5412,7 @@
         </p:nvSpPr>
         <p:spPr>
           <a:xfrm>
-            <a:off x="1280160" y="1280160"/>
+            <a:off x="1577340" y="1280160"/>
             <a:ext cx="548640" cy="548640"/>
           </a:xfrm>
           <a:prstGeom prst="ellipse">
@@ -5432,7 +5432,7 @@
         </p:nvSpPr>
         <p:spPr>
           <a:xfrm>
-            <a:off x="1280160" y="1280160"/>
+            <a:off x="1577340" y="1280160"/>
             <a:ext cx="548640" cy="548640"/>
           </a:xfrm>
           <a:prstGeom prst="rect">
@@ -5468,8 +5468,8 @@
         </p:nvSpPr>
         <p:spPr>
           <a:xfrm>
-            <a:off x="1920240" y="1554480"/>
-            <a:ext cx="1538935" cy="0"/>
+            <a:off x="2217420" y="1554480"/>
+            <a:ext cx="2096719" cy="0"/>
           </a:xfrm>
           <a:prstGeom prst="line">
             <a:avLst/>
@@ -5493,7 +5493,7 @@
         <p:spPr>
           <a:xfrm>
             <a:off x="548640" y="1920240"/>
-            <a:ext cx="2011680" cy="365760"/>
+            <a:ext cx="2606040" cy="365760"/>
           </a:xfrm>
           <a:prstGeom prst="rect">
             <a:avLst/>
@@ -5514,7 +5514,7 @@
                   <a:schemeClr val="tx2"/>
                 </a:solidFill>
               </a:rPr>
-              <a:t>线上种草</a:t>
+              <a:t>种草</a:t>
             </a:r>
             <a:endParaRPr lang="en-US" sz="1600" dirty="0"/>
           </a:p>
@@ -5529,7 +5529,7 @@
         <p:spPr>
           <a:xfrm>
             <a:off x="548640" y="2286000"/>
-            <a:ext cx="2011680" cy="502920"/>
+            <a:ext cx="2606040" cy="502920"/>
           </a:xfrm>
           <a:prstGeom prst="rect">
             <a:avLst/>
@@ -5565,7 +5565,7 @@
         <p:spPr>
           <a:xfrm>
             <a:off x="548640" y="2880360"/>
-            <a:ext cx="2011680" cy="1005840"/>
+            <a:ext cx="2606040" cy="1005840"/>
           </a:xfrm>
           <a:prstGeom prst="roundRect">
             <a:avLst>
@@ -5587,7 +5587,7 @@
         <p:spPr>
           <a:xfrm>
             <a:off x="685800" y="2926080"/>
-            <a:ext cx="1737360" cy="914400"/>
+            <a:ext cx="2331720" cy="914400"/>
           </a:xfrm>
           <a:prstGeom prst="rect">
             <a:avLst/>
@@ -5643,7 +5643,7 @@
         <p:spPr>
           <a:xfrm>
             <a:off x="548640" y="4069080"/>
-            <a:ext cx="2011680" cy="1325880"/>
+            <a:ext cx="2606040" cy="1325880"/>
           </a:xfrm>
           <a:prstGeom prst="roundRect">
             <a:avLst>
@@ -5670,7 +5670,7 @@
         <p:spPr>
           <a:xfrm>
             <a:off x="658368" y="4114800"/>
-            <a:ext cx="1792224" cy="1234440"/>
+            <a:ext cx="2386584" cy="1234440"/>
           </a:xfrm>
           <a:prstGeom prst="rect">
             <a:avLst/>
@@ -5725,7 +5725,7 @@
         </p:nvSpPr>
         <p:spPr>
           <a:xfrm>
-            <a:off x="3550615" y="1280160"/>
+            <a:off x="4405579" y="1280160"/>
             <a:ext cx="548640" cy="548640"/>
           </a:xfrm>
           <a:prstGeom prst="ellipse">
@@ -5745,7 +5745,7 @@
         </p:nvSpPr>
         <p:spPr>
           <a:xfrm>
-            <a:off x="3550615" y="1280160"/>
+            <a:off x="4405579" y="1280160"/>
             <a:ext cx="548640" cy="548640"/>
           </a:xfrm>
           <a:prstGeom prst="rect">
@@ -5781,8 +5781,8 @@
         </p:nvSpPr>
         <p:spPr>
           <a:xfrm>
-            <a:off x="4190695" y="1554480"/>
-            <a:ext cx="1538935" cy="0"/>
+            <a:off x="5045659" y="1554480"/>
+            <a:ext cx="2096719" cy="0"/>
           </a:xfrm>
           <a:prstGeom prst="line">
             <a:avLst/>
@@ -5805,8 +5805,8 @@
         </p:nvSpPr>
         <p:spPr>
           <a:xfrm>
-            <a:off x="2819095" y="1920240"/>
-            <a:ext cx="2011680" cy="365760"/>
+            <a:off x="3376879" y="1920240"/>
+            <a:ext cx="2606040" cy="365760"/>
           </a:xfrm>
           <a:prstGeom prst="rect">
             <a:avLst/>
@@ -5827,7 +5827,7 @@
                   <a:schemeClr val="tx2"/>
                 </a:solidFill>
               </a:rPr>
-              <a:t>到店尝鲜</a:t>
+              <a:t>尝鲜</a:t>
             </a:r>
             <a:endParaRPr lang="en-US" sz="1600" dirty="0"/>
           </a:p>
@@ -5841,8 +5841,8 @@
         </p:nvSpPr>
         <p:spPr>
           <a:xfrm>
-            <a:off x="2819095" y="2286000"/>
-            <a:ext cx="2011680" cy="502920"/>
+            <a:off x="3376879" y="2286000"/>
+            <a:ext cx="2606040" cy="502920"/>
           </a:xfrm>
           <a:prstGeom prst="rect">
             <a:avLst/>
@@ -5863,7 +5863,7 @@
                   <a:schemeClr val="tx1"/>
                 </a:solidFill>
               </a:rPr>
-              <a:t>去最近的量贩店买一小包</a:t>
+              <a:t>去最近的量贩店买一小包，第一口不好吃就不再买</a:t>
             </a:r>
             <a:endParaRPr lang="en-US" sz="1300" dirty="0"/>
           </a:p>
@@ -5877,8 +5877,8 @@
         </p:nvSpPr>
         <p:spPr>
           <a:xfrm>
-            <a:off x="2819095" y="2880360"/>
-            <a:ext cx="2011680" cy="1005840"/>
+            <a:off x="3376879" y="2880360"/>
+            <a:ext cx="2606040" cy="1005840"/>
           </a:xfrm>
           <a:prstGeom prst="roundRect">
             <a:avLst>
@@ -5899,8 +5899,8 @@
         </p:nvSpPr>
         <p:spPr>
           <a:xfrm>
-            <a:off x="2956255" y="2926080"/>
-            <a:ext cx="1737360" cy="914400"/>
+            <a:off x="3514039" y="2926080"/>
+            <a:ext cx="2331720" cy="914400"/>
           </a:xfrm>
           <a:prstGeom prst="rect">
             <a:avLst/>
@@ -5941,7 +5941,7 @@
                   <a:schemeClr val="tx2"/>
                 </a:solidFill>
               </a:rPr>
-              <a:t>店里不显眼，找不到</a:t>
+              <a:t>店里找不到；“枣”像养生品，不想试</a:t>
             </a:r>
             <a:endParaRPr lang="en-US" sz="1000" dirty="0"/>
           </a:p>
@@ -5955,8 +5955,8 @@
         </p:nvSpPr>
         <p:spPr>
           <a:xfrm>
-            <a:off x="2819095" y="4069080"/>
-            <a:ext cx="2011680" cy="1325880"/>
+            <a:off x="3376879" y="4069080"/>
+            <a:ext cx="2606040" cy="1325880"/>
           </a:xfrm>
           <a:prstGeom prst="roundRect">
             <a:avLst>
@@ -5982,8 +5982,8 @@
         </p:nvSpPr>
         <p:spPr>
           <a:xfrm>
-            <a:off x="2928823" y="4114800"/>
-            <a:ext cx="1792224" cy="1234440"/>
+            <a:off x="3486607" y="4114800"/>
+            <a:ext cx="2386584" cy="1234440"/>
           </a:xfrm>
           <a:prstGeom prst="rect">
             <a:avLst/>
@@ -6038,7 +6038,7 @@
         </p:nvSpPr>
         <p:spPr>
           <a:xfrm>
-            <a:off x="5821070" y="1280160"/>
+            <a:off x="7233818" y="1280160"/>
             <a:ext cx="548640" cy="548640"/>
           </a:xfrm>
           <a:prstGeom prst="ellipse">
@@ -6058,7 +6058,7 @@
         </p:nvSpPr>
         <p:spPr>
           <a:xfrm>
-            <a:off x="5821070" y="1280160"/>
+            <a:off x="7233818" y="1280160"/>
             <a:ext cx="548640" cy="548640"/>
           </a:xfrm>
           <a:prstGeom prst="rect">
@@ -6094,8 +6094,8 @@
         </p:nvSpPr>
         <p:spPr>
           <a:xfrm>
-            <a:off x="6461150" y="1554480"/>
-            <a:ext cx="1538935" cy="0"/>
+            <a:off x="7873898" y="1554480"/>
+            <a:ext cx="2096719" cy="0"/>
           </a:xfrm>
           <a:prstGeom prst="line">
             <a:avLst/>
@@ -6118,8 +6118,8 @@
         </p:nvSpPr>
         <p:spPr>
           <a:xfrm>
-            <a:off x="5089550" y="1920240"/>
-            <a:ext cx="2011680" cy="365760"/>
+            <a:off x="6205118" y="1920240"/>
+            <a:ext cx="2606040" cy="365760"/>
           </a:xfrm>
           <a:prstGeom prst="rect">
             <a:avLst/>
@@ -6140,7 +6140,7 @@
                   <a:schemeClr val="tx2"/>
                 </a:solidFill>
               </a:rPr>
-              <a:t>第一口判断</a:t>
+              <a:t>验证</a:t>
             </a:r>
             <a:endParaRPr lang="en-US" sz="1600" dirty="0"/>
           </a:p>
@@ -6154,8 +6154,8 @@
         </p:nvSpPr>
         <p:spPr>
           <a:xfrm>
-            <a:off x="5089550" y="2286000"/>
-            <a:ext cx="2011680" cy="502920"/>
+            <a:off x="6205118" y="2286000"/>
+            <a:ext cx="2606040" cy="502920"/>
           </a:xfrm>
           <a:prstGeom prst="rect">
             <a:avLst/>
@@ -6176,7 +6176,7 @@
                   <a:schemeClr val="tx1"/>
                 </a:solidFill>
               </a:rPr>
-              <a:t>不好吃就不会再买</a:t>
+              <a:t>吃完查配料表、含糖量</a:t>
             </a:r>
             <a:endParaRPr lang="en-US" sz="1300" dirty="0"/>
           </a:p>
@@ -6190,8 +6190,8 @@
         </p:nvSpPr>
         <p:spPr>
           <a:xfrm>
-            <a:off x="5089550" y="2880360"/>
-            <a:ext cx="2011680" cy="1005840"/>
+            <a:off x="6205118" y="2880360"/>
+            <a:ext cx="2606040" cy="1005840"/>
           </a:xfrm>
           <a:prstGeom prst="roundRect">
             <a:avLst>
@@ -6212,8 +6212,8 @@
         </p:nvSpPr>
         <p:spPr>
           <a:xfrm>
-            <a:off x="5226710" y="2926080"/>
-            <a:ext cx="1737360" cy="914400"/>
+            <a:off x="6342278" y="2926080"/>
+            <a:ext cx="2331720" cy="914400"/>
           </a:xfrm>
           <a:prstGeom prst="rect">
             <a:avLst/>
@@ -6254,7 +6254,7 @@
                   <a:schemeClr val="tx2"/>
                 </a:solidFill>
               </a:rPr>
-              <a:t>“枣”像养生品，不想试</a:t>
+              <a:t>包装没回答健康问题</a:t>
             </a:r>
             <a:endParaRPr lang="en-US" sz="1000" dirty="0"/>
           </a:p>
@@ -6268,8 +6268,8 @@
         </p:nvSpPr>
         <p:spPr>
           <a:xfrm>
-            <a:off x="5089550" y="4069080"/>
-            <a:ext cx="2011680" cy="1325880"/>
+            <a:off x="6205118" y="4069080"/>
+            <a:ext cx="2606040" cy="1325880"/>
           </a:xfrm>
           <a:prstGeom prst="roundRect">
             <a:avLst>
@@ -6295,8 +6295,8 @@
         </p:nvSpPr>
         <p:spPr>
           <a:xfrm>
-            <a:off x="5199278" y="4114800"/>
-            <a:ext cx="1792224" cy="1234440"/>
+            <a:off x="6314846" y="4114800"/>
+            <a:ext cx="2386584" cy="1234440"/>
           </a:xfrm>
           <a:prstGeom prst="rect">
             <a:avLst/>
@@ -6315,14 +6315,14 @@
               <a:buNone/>
             </a:pPr>
             <a:r>
-              <a:rPr lang="en-US" sz="1400" b="1" dirty="0">
-                <a:solidFill>
-                  <a:schemeClr val="tx2"/>
-                </a:solidFill>
-              </a:rPr>
-              <a:t>“好吃就会回购”</a:t>
-            </a:r>
-            <a:endParaRPr lang="en-US" sz="1400" dirty="0"/>
+              <a:rPr lang="en-US" sz="2600" b="1" dirty="0">
+                <a:solidFill>
+                  <a:schemeClr val="accent1"/>
+                </a:solidFill>
+              </a:rPr>
+              <a:t>9/15</a:t>
+            </a:r>
+            <a:endParaRPr lang="en-US" sz="2600" dirty="0"/>
           </a:p>
           <a:p>
             <a:pPr algn="ctr" indent="0" marL="0">
@@ -6337,9 +6337,9 @@
                   <a:schemeClr val="accent3"/>
                 </a:solidFill>
               </a:rPr>
-              <a:t>F8，大三</a:t>
-            </a:r>
-            <a:endParaRPr lang="en-US" sz="1400" dirty="0"/>
+              <a:t>吃完会查配料或含糖量</a:t>
+            </a:r>
+            <a:endParaRPr lang="en-US" sz="2600" dirty="0"/>
           </a:p>
         </p:txBody>
       </p:sp>
@@ -6351,7 +6351,7 @@
         </p:nvSpPr>
         <p:spPr>
           <a:xfrm>
-            <a:off x="8091526" y="1280160"/>
+            <a:off x="10062058" y="1280160"/>
             <a:ext cx="548640" cy="548640"/>
           </a:xfrm>
           <a:prstGeom prst="ellipse">
@@ -6371,7 +6371,7 @@
         </p:nvSpPr>
         <p:spPr>
           <a:xfrm>
-            <a:off x="8091526" y="1280160"/>
+            <a:off x="10062058" y="1280160"/>
             <a:ext cx="548640" cy="548640"/>
           </a:xfrm>
           <a:prstGeom prst="rect">
@@ -6401,27 +6401,39 @@
       </p:sp>
       <p:sp>
         <p:nvSpPr>
-          <p:cNvPr id="34" name="Shape 32"/>
-          <p:cNvSpPr/>
-          <p:nvPr/>
-        </p:nvSpPr>
-        <p:spPr>
-          <a:xfrm>
-            <a:off x="8731606" y="1554480"/>
-            <a:ext cx="1538935" cy="0"/>
-          </a:xfrm>
-          <a:prstGeom prst="line">
-            <a:avLst/>
-          </a:prstGeom>
-          <a:noFill/>
-          <a:ln w="19050">
-            <a:solidFill>
-              <a:srgbClr val="7A1426"/>
-            </a:solidFill>
-            <a:prstDash val="solid"/>
-            <a:tailEnd type="triangle"/>
-          </a:ln>
-        </p:spPr>
+          <p:cNvPr id="34" name="Text 32"/>
+          <p:cNvSpPr txBox="1"/>
+          <p:nvPr/>
+        </p:nvSpPr>
+        <p:spPr>
+          <a:xfrm>
+            <a:off x="9033358" y="1920240"/>
+            <a:ext cx="2606040" cy="365760"/>
+          </a:xfrm>
+          <a:prstGeom prst="rect">
+            <a:avLst/>
+          </a:prstGeom>
+          <a:noFill/>
+          <a:ln/>
+        </p:spPr>
+        <p:txBody>
+          <a:bodyPr wrap="square" lIns="0" tIns="0" rIns="0" bIns="0" rtlCol="0" anchor="ctr"/>
+          <a:lstStyle/>
+          <a:p>
+            <a:pPr algn="ctr" indent="0" marL="0">
+              <a:buNone/>
+            </a:pPr>
+            <a:r>
+              <a:rPr lang="en-US" sz="1600" b="1" dirty="0">
+                <a:solidFill>
+                  <a:schemeClr val="tx2"/>
+                </a:solidFill>
+              </a:rPr>
+              <a:t>复购</a:t>
+            </a:r>
+            <a:endParaRPr lang="en-US" sz="1600" dirty="0"/>
+          </a:p>
+        </p:txBody>
       </p:sp>
       <p:sp>
         <p:nvSpPr>
@@ -6431,65 +6443,29 @@
         </p:nvSpPr>
         <p:spPr>
           <a:xfrm>
-            <a:off x="7360006" y="1920240"/>
-            <a:ext cx="2011680" cy="365760"/>
-          </a:xfrm>
-          <a:prstGeom prst="rect">
-            <a:avLst/>
-          </a:prstGeom>
-          <a:noFill/>
-          <a:ln/>
-        </p:spPr>
-        <p:txBody>
-          <a:bodyPr wrap="square" lIns="0" tIns="0" rIns="0" bIns="0" rtlCol="0" anchor="ctr"/>
+            <a:off x="9033358" y="2286000"/>
+            <a:ext cx="2606040" cy="502920"/>
+          </a:xfrm>
+          <a:prstGeom prst="rect">
+            <a:avLst/>
+          </a:prstGeom>
+          <a:noFill/>
+          <a:ln/>
+        </p:spPr>
+        <p:txBody>
+          <a:bodyPr wrap="square" lIns="0" tIns="0" rIns="0" bIns="0" rtlCol="0" anchor="t"/>
           <a:lstStyle/>
           <a:p>
             <a:pPr algn="ctr" indent="0" marL="0">
               <a:buNone/>
             </a:pPr>
             <a:r>
-              <a:rPr lang="en-US" sz="1600" b="1" dirty="0">
-                <a:solidFill>
-                  <a:schemeClr val="tx2"/>
-                </a:solidFill>
-              </a:rPr>
-              <a:t>吃后验证</a:t>
-            </a:r>
-            <a:endParaRPr lang="en-US" sz="1600" dirty="0"/>
-          </a:p>
-        </p:txBody>
-      </p:sp>
-      <p:sp>
-        <p:nvSpPr>
-          <p:cNvPr id="36" name="Text 34"/>
-          <p:cNvSpPr txBox="1"/>
-          <p:nvPr/>
-        </p:nvSpPr>
-        <p:spPr>
-          <a:xfrm>
-            <a:off x="7360006" y="2286000"/>
-            <a:ext cx="2011680" cy="502920"/>
-          </a:xfrm>
-          <a:prstGeom prst="rect">
-            <a:avLst/>
-          </a:prstGeom>
-          <a:noFill/>
-          <a:ln/>
-        </p:spPr>
-        <p:txBody>
-          <a:bodyPr wrap="square" lIns="0" tIns="0" rIns="0" bIns="0" rtlCol="0" anchor="t"/>
-          <a:lstStyle/>
-          <a:p>
-            <a:pPr algn="ctr" indent="0" marL="0">
-              <a:buNone/>
-            </a:pPr>
-            <a:r>
               <a:rPr lang="en-US" sz="1300" dirty="0">
                 <a:solidFill>
                   <a:schemeClr val="tx1"/>
                 </a:solidFill>
               </a:rPr>
-              <a:t>查配料表、含糖量</a:t>
+              <a:t>认准一个品牌或一家店</a:t>
             </a:r>
             <a:endParaRPr lang="en-US" sz="1300" dirty="0"/>
           </a:p>
@@ -6497,14 +6473,14 @@
       </p:sp>
       <p:sp>
         <p:nvSpPr>
-          <p:cNvPr id="37" name="stuck-4"/>
-          <p:cNvSpPr/>
-          <p:nvPr/>
-        </p:nvSpPr>
-        <p:spPr>
-          <a:xfrm>
-            <a:off x="7360006" y="2880360"/>
-            <a:ext cx="2011680" cy="1005840"/>
+          <p:cNvPr id="36" name="stuck-4"/>
+          <p:cNvSpPr/>
+          <p:nvPr/>
+        </p:nvSpPr>
+        <p:spPr>
+          <a:xfrm>
+            <a:off x="9033358" y="2880360"/>
+            <a:ext cx="2606040" cy="1005840"/>
           </a:xfrm>
           <a:prstGeom prst="roundRect">
             <a:avLst>
@@ -6519,14 +6495,14 @@
       </p:sp>
       <p:sp>
         <p:nvSpPr>
-          <p:cNvPr id="38" name="Text 36"/>
+          <p:cNvPr id="37" name="Text 35"/>
           <p:cNvSpPr txBox="1"/>
           <p:nvPr/>
         </p:nvSpPr>
         <p:spPr>
           <a:xfrm>
-            <a:off x="7497166" y="2926080"/>
-            <a:ext cx="1737360" cy="914400"/>
+            <a:off x="9170518" y="2926080"/>
+            <a:ext cx="2331720" cy="914400"/>
           </a:xfrm>
           <a:prstGeom prst="rect">
             <a:avLst/>
@@ -6567,7 +6543,7 @@
                   <a:schemeClr val="tx2"/>
                 </a:solidFill>
               </a:rPr>
-              <a:t>包装没回答健康问题</a:t>
+              <a:t>没有再买的理由</a:t>
             </a:r>
             <a:endParaRPr lang="en-US" sz="1000" dirty="0"/>
           </a:p>
@@ -6575,14 +6551,14 @@
       </p:sp>
       <p:sp>
         <p:nvSpPr>
-          <p:cNvPr id="39" name="evidence-4"/>
-          <p:cNvSpPr/>
-          <p:nvPr/>
-        </p:nvSpPr>
-        <p:spPr>
-          <a:xfrm>
-            <a:off x="7360006" y="4069080"/>
-            <a:ext cx="2011680" cy="1325880"/>
+          <p:cNvPr id="38" name="evidence-4"/>
+          <p:cNvSpPr/>
+          <p:nvPr/>
+        </p:nvSpPr>
+        <p:spPr>
+          <a:xfrm>
+            <a:off x="9033358" y="4069080"/>
+            <a:ext cx="2606040" cy="1325880"/>
           </a:xfrm>
           <a:prstGeom prst="roundRect">
             <a:avLst>
@@ -6602,14 +6578,14 @@
       </p:sp>
       <p:sp>
         <p:nvSpPr>
-          <p:cNvPr id="40" name="Text 38"/>
+          <p:cNvPr id="39" name="Text 37"/>
           <p:cNvSpPr txBox="1"/>
           <p:nvPr/>
         </p:nvSpPr>
         <p:spPr>
           <a:xfrm>
-            <a:off x="7469734" y="4114800"/>
-            <a:ext cx="1792224" cy="1234440"/>
+            <a:off x="9143086" y="4114800"/>
+            <a:ext cx="2386584" cy="1234440"/>
           </a:xfrm>
           <a:prstGeom prst="rect">
             <a:avLst/>
@@ -6628,14 +6604,14 @@
               <a:buNone/>
             </a:pPr>
             <a:r>
-              <a:rPr lang="en-US" sz="2600" b="1" dirty="0">
-                <a:solidFill>
-                  <a:schemeClr val="accent1"/>
-                </a:solidFill>
-              </a:rPr>
-              <a:t>9/15</a:t>
-            </a:r>
-            <a:endParaRPr lang="en-US" sz="2600" dirty="0"/>
+              <a:rPr lang="en-US" sz="1400" b="1" dirty="0">
+                <a:solidFill>
+                  <a:schemeClr val="tx2"/>
+                </a:solidFill>
+              </a:rPr>
+              <a:t>“同一家店一直有货”</a:t>
+            </a:r>
+            <a:endParaRPr lang="en-US" sz="1400" dirty="0"/>
           </a:p>
           <a:p>
             <a:pPr algn="ctr" indent="0" marL="0">
@@ -6650,304 +6626,15 @@
                   <a:schemeClr val="accent3"/>
                 </a:solidFill>
               </a:rPr>
-              <a:t>吃完会查配料或含糖量</a:t>
-            </a:r>
-            <a:endParaRPr lang="en-US" sz="2600" dirty="0"/>
-          </a:p>
-        </p:txBody>
-      </p:sp>
-      <p:sp>
-        <p:nvSpPr>
-          <p:cNvPr id="41" name="step-5"/>
-          <p:cNvSpPr/>
-          <p:nvPr/>
-        </p:nvSpPr>
-        <p:spPr>
-          <a:xfrm>
-            <a:off x="10361981" y="1280160"/>
-            <a:ext cx="548640" cy="548640"/>
-          </a:xfrm>
-          <a:prstGeom prst="ellipse">
-            <a:avLst/>
-          </a:prstGeom>
-          <a:solidFill>
-            <a:schemeClr val="tx2"/>
-          </a:solidFill>
-          <a:ln/>
-        </p:spPr>
-      </p:sp>
-      <p:sp>
-        <p:nvSpPr>
-          <p:cNvPr id="42" name="Text 40"/>
-          <p:cNvSpPr txBox="1"/>
-          <p:nvPr/>
-        </p:nvSpPr>
-        <p:spPr>
-          <a:xfrm>
-            <a:off x="10361981" y="1280160"/>
-            <a:ext cx="548640" cy="548640"/>
-          </a:xfrm>
-          <a:prstGeom prst="rect">
-            <a:avLst/>
-          </a:prstGeom>
-          <a:noFill/>
-          <a:ln/>
-        </p:spPr>
-        <p:txBody>
-          <a:bodyPr wrap="square" lIns="0" tIns="0" rIns="0" bIns="0" rtlCol="0" anchor="ctr"/>
-          <a:lstStyle/>
-          <a:p>
-            <a:pPr algn="ctr" indent="0" marL="0">
-              <a:buNone/>
-            </a:pPr>
-            <a:r>
-              <a:rPr lang="en-US" sz="1800" b="1" dirty="0">
-                <a:solidFill>
-                  <a:schemeClr val="bg2"/>
-                </a:solidFill>
-              </a:rPr>
-              <a:t>5</a:t>
-            </a:r>
-            <a:endParaRPr lang="en-US" sz="1800" dirty="0"/>
-          </a:p>
-        </p:txBody>
-      </p:sp>
-      <p:sp>
-        <p:nvSpPr>
-          <p:cNvPr id="43" name="Text 41"/>
-          <p:cNvSpPr txBox="1"/>
-          <p:nvPr/>
-        </p:nvSpPr>
-        <p:spPr>
-          <a:xfrm>
-            <a:off x="9630461" y="1920240"/>
-            <a:ext cx="2011680" cy="365760"/>
-          </a:xfrm>
-          <a:prstGeom prst="rect">
-            <a:avLst/>
-          </a:prstGeom>
-          <a:noFill/>
-          <a:ln/>
-        </p:spPr>
-        <p:txBody>
-          <a:bodyPr wrap="square" lIns="0" tIns="0" rIns="0" bIns="0" rtlCol="0" anchor="ctr"/>
-          <a:lstStyle/>
-          <a:p>
-            <a:pPr algn="ctr" indent="0" marL="0">
-              <a:buNone/>
-            </a:pPr>
-            <a:r>
-              <a:rPr lang="en-US" sz="1600" b="1" dirty="0">
-                <a:solidFill>
-                  <a:schemeClr val="tx2"/>
-                </a:solidFill>
-              </a:rPr>
-              <a:t>复购留存</a:t>
-            </a:r>
-            <a:endParaRPr lang="en-US" sz="1600" dirty="0"/>
-          </a:p>
-        </p:txBody>
-      </p:sp>
-      <p:sp>
-        <p:nvSpPr>
-          <p:cNvPr id="44" name="Text 42"/>
-          <p:cNvSpPr txBox="1"/>
-          <p:nvPr/>
-        </p:nvSpPr>
-        <p:spPr>
-          <a:xfrm>
-            <a:off x="9630461" y="2286000"/>
-            <a:ext cx="2011680" cy="502920"/>
-          </a:xfrm>
-          <a:prstGeom prst="rect">
-            <a:avLst/>
-          </a:prstGeom>
-          <a:noFill/>
-          <a:ln/>
-        </p:spPr>
-        <p:txBody>
-          <a:bodyPr wrap="square" lIns="0" tIns="0" rIns="0" bIns="0" rtlCol="0" anchor="t"/>
-          <a:lstStyle/>
-          <a:p>
-            <a:pPr algn="ctr" indent="0" marL="0">
-              <a:buNone/>
-            </a:pPr>
-            <a:r>
-              <a:rPr lang="en-US" sz="1300" dirty="0">
-                <a:solidFill>
-                  <a:schemeClr val="tx1"/>
-                </a:solidFill>
-              </a:rPr>
-              <a:t>认准一个品牌或一家店</a:t>
-            </a:r>
-            <a:endParaRPr lang="en-US" sz="1300" dirty="0"/>
-          </a:p>
-        </p:txBody>
-      </p:sp>
-      <p:sp>
-        <p:nvSpPr>
-          <p:cNvPr id="45" name="stuck-5"/>
-          <p:cNvSpPr/>
-          <p:nvPr/>
-        </p:nvSpPr>
-        <p:spPr>
-          <a:xfrm>
-            <a:off x="9630461" y="2880360"/>
-            <a:ext cx="2011680" cy="1005840"/>
-          </a:xfrm>
-          <a:prstGeom prst="roundRect">
-            <a:avLst>
-              <a:gd name="adj" fmla="val 7273"/>
-            </a:avLst>
-          </a:prstGeom>
-          <a:solidFill>
-            <a:schemeClr val="accent5"/>
-          </a:solidFill>
-          <a:ln/>
-        </p:spPr>
-      </p:sp>
-      <p:sp>
-        <p:nvSpPr>
-          <p:cNvPr id="46" name="Text 44"/>
-          <p:cNvSpPr txBox="1"/>
-          <p:nvPr/>
-        </p:nvSpPr>
-        <p:spPr>
-          <a:xfrm>
-            <a:off x="9767621" y="2926080"/>
-            <a:ext cx="1737360" cy="914400"/>
-          </a:xfrm>
-          <a:prstGeom prst="rect">
-            <a:avLst/>
-          </a:prstGeom>
-          <a:noFill/>
-          <a:ln/>
-        </p:spPr>
-        <p:txBody>
-          <a:bodyPr wrap="square" lIns="0" tIns="0" rIns="0" bIns="0" rtlCol="0" anchor="ctr"/>
-          <a:lstStyle/>
-          <a:p>
-            <a:pPr algn="ctr" indent="0" marL="0">
-              <a:spcAft>
-                <a:spcPts val="300"/>
-              </a:spcAft>
-              <a:buNone/>
-            </a:pPr>
-            <a:r>
-              <a:rPr lang="en-US" sz="1000" b="1" dirty="0">
-                <a:solidFill>
-                  <a:schemeClr val="accent1"/>
-                </a:solidFill>
-              </a:rPr>
-              <a:t>美枣王卡在这</a:t>
-            </a:r>
-            <a:endParaRPr lang="en-US" sz="1000" dirty="0"/>
-          </a:p>
-          <a:p>
-            <a:pPr algn="ctr" indent="0" marL="0">
-              <a:spcAft>
-                <a:spcPts val="300"/>
-              </a:spcAft>
-              <a:buNone/>
-            </a:pPr>
-            <a:r>
-              <a:rPr lang="en-US" sz="1400" b="1" dirty="0">
-                <a:solidFill>
-                  <a:schemeClr val="tx2"/>
-                </a:solidFill>
-              </a:rPr>
-              <a:t>没有再买的理由</a:t>
-            </a:r>
-            <a:endParaRPr lang="en-US" sz="1000" dirty="0"/>
-          </a:p>
-        </p:txBody>
-      </p:sp>
-      <p:sp>
-        <p:nvSpPr>
-          <p:cNvPr id="47" name="evidence-5"/>
-          <p:cNvSpPr/>
-          <p:nvPr/>
-        </p:nvSpPr>
-        <p:spPr>
-          <a:xfrm>
-            <a:off x="9630461" y="4069080"/>
-            <a:ext cx="2011680" cy="1325880"/>
-          </a:xfrm>
-          <a:prstGeom prst="roundRect">
-            <a:avLst>
-              <a:gd name="adj" fmla="val 6897"/>
-            </a:avLst>
-          </a:prstGeom>
-          <a:solidFill>
-            <a:srgbClr val="FFFFFF"/>
-          </a:solidFill>
-          <a:ln w="9525">
-            <a:solidFill>
-              <a:srgbClr val="D9CBC4"/>
-            </a:solidFill>
-            <a:prstDash val="solid"/>
-          </a:ln>
-        </p:spPr>
-      </p:sp>
-      <p:sp>
-        <p:nvSpPr>
-          <p:cNvPr id="48" name="Text 46"/>
-          <p:cNvSpPr txBox="1"/>
-          <p:nvPr/>
-        </p:nvSpPr>
-        <p:spPr>
-          <a:xfrm>
-            <a:off x="9740189" y="4114800"/>
-            <a:ext cx="1792224" cy="1234440"/>
-          </a:xfrm>
-          <a:prstGeom prst="rect">
-            <a:avLst/>
-          </a:prstGeom>
-          <a:noFill/>
-          <a:ln/>
-        </p:spPr>
-        <p:txBody>
-          <a:bodyPr wrap="square" lIns="0" tIns="0" rIns="0" bIns="0" rtlCol="0" anchor="ctr"/>
-          <a:lstStyle/>
-          <a:p>
-            <a:pPr algn="ctr" indent="0" marL="0">
-              <a:spcAft>
-                <a:spcPts val="200"/>
-              </a:spcAft>
-              <a:buNone/>
-            </a:pPr>
-            <a:r>
-              <a:rPr lang="en-US" sz="1400" b="1" dirty="0">
-                <a:solidFill>
-                  <a:schemeClr val="tx2"/>
-                </a:solidFill>
-              </a:rPr>
-              <a:t>“同一家店一直有货”</a:t>
+              <a:t>F1，大三</a:t>
             </a:r>
             <a:endParaRPr lang="en-US" sz="1400" dirty="0"/>
           </a:p>
-          <a:p>
-            <a:pPr algn="ctr" indent="0" marL="0">
-              <a:spcAft>
-                <a:spcPts val="200"/>
-              </a:spcAft>
-              <a:buNone/>
-            </a:pPr>
-            <a:r>
-              <a:rPr lang="en-US" sz="1100" dirty="0">
-                <a:solidFill>
-                  <a:schemeClr val="accent3"/>
-                </a:solidFill>
-              </a:rPr>
-              <a:t>F1，大三</a:t>
-            </a:r>
-            <a:endParaRPr lang="en-US" sz="1400" dirty="0"/>
-          </a:p>
-        </p:txBody>
-      </p:sp>
-      <p:sp>
-        <p:nvSpPr>
-          <p:cNvPr id="49" name="Text 47"/>
+        </p:txBody>
+      </p:sp>
+      <p:sp>
+        <p:nvSpPr>
+          <p:cNvPr id="40" name="Text 38"/>
           <p:cNvSpPr txBox="1"/>
           <p:nvPr/>
         </p:nvSpPr>
@@ -6983,7 +6670,7 @@
       </p:sp>
       <p:sp>
         <p:nvSpPr>
-          <p:cNvPr id="50" name="path-conclusion"/>
+          <p:cNvPr id="41" name="path-conclusion"/>
           <p:cNvSpPr/>
           <p:nvPr/>
         </p:nvSpPr>
@@ -7005,7 +6692,7 @@
       </p:sp>
       <p:sp>
         <p:nvSpPr>
-          <p:cNvPr id="51" name="Text 49"/>
+          <p:cNvPr id="42" name="Text 40"/>
           <p:cNvSpPr txBox="1"/>
           <p:nvPr/>
         </p:nvSpPr>
@@ -7033,7 +6720,7 @@
                   <a:schemeClr val="bg2"/>
                 </a:solidFill>
               </a:rPr>
-              <a:t>种草→尝鲜→第一口→验证→复购：问题不只在“第一次买”，而在买完之后没有被记住</a:t>
+              <a:t>种草→尝鲜→验证→复购：问题不只在“第一次买”，而在买完之后没有被记住</a:t>
             </a:r>
             <a:endParaRPr lang="en-US" sz="1500" dirty="0"/>
           </a:p>
@@ -8661,7 +8348,7 @@
                   <a:schemeClr val="tx2"/>
                 </a:solidFill>
               </a:rPr>
-              <a:t>画出五步购买路径</a:t>
+              <a:t>画出四步购买路径</a:t>
             </a:r>
             <a:endParaRPr lang="en-US" sz="1300" dirty="0"/>
           </a:p>

</xml_diff>

<commit_message>
Use transcript for appendix one and verified quotes in chapter 5, P4 and personal assignment
Co-Authored-By: Claude Opus 5.5 <noreply@anthropic.com>
Claude-Session: https://claude.ai/code/session_01CU6W6huYbDSXyzWhJKPgvt
</commit_message>
<xml_diff>
--- a/ppt/v4/制作1_封面目录分隔页_P2-P5_P14-P15.pptx
+++ b/ppt/v4/制作1_封面目录分隔页_P2-P5_P14-P15.pptx
@@ -117,13 +117,13 @@
   <p:extLst>
     <p:ext uri="{521415D9-36F7-43E2-AB2F-B90AF26B5E84}">
       <p14:sectionLst xmlns:p14="http://schemas.microsoft.com/office/powerpoint/2010/main">
-        <p14:section name="开场" id="{30a571b1-1f87-a54c-e5c6-4334db7f295f}">
+        <p14:section name="开场" id="{02a86ff6-066e-75e8-eedc-933373fce55e}">
           <p14:sldIdLst>
             <p14:sldId id="256"/>
             <p14:sldId id="257"/>
           </p14:sldIdLst>
         </p14:section>
-        <p14:section name="背景与问题" id="{4c5b3b49-f2c7-7791-a8f9-93f122714c10}">
+        <p14:section name="背景与问题" id="{ca3003b1-bed8-e8ac-b6b5-7e336a387d1a}">
           <p14:sldIdLst>
             <p14:sldId id="258"/>
             <p14:sldId id="259"/>
@@ -132,13 +132,13 @@
             <p14:sldId id="262"/>
           </p14:sldIdLst>
         </p14:section>
-        <p14:section name="分隔页（插到方案、执行部分前）" id="{26f8b96f-0055-15c7-8bd0-f46272af90b9}">
+        <p14:section name="分隔页（插到方案、执行部分前）" id="{1b25d176-5d95-6a12-e779-97b631607396}">
           <p14:sldIdLst>
             <p14:sldId id="263"/>
             <p14:sldId id="264"/>
           </p14:sldIdLst>
         </p14:section>
-        <p14:section name="总结与封底" id="{55a1a3d4-23f1-1ea8-1977-0ffc33d666c6}">
+        <p14:section name="总结与封底" id="{28b5d3df-26ce-eca2-e0c4-8156cbcbe933}">
           <p14:sldIdLst>
             <p14:sldId id="265"/>
             <p14:sldId id="266"/>
@@ -7812,7 +7812,7 @@
                   <a:schemeClr val="tx2"/>
                 </a:solidFill>
               </a:rPr>
-              <a:t>零食消费“更多是一个尝鲜”，尝了不错才会继续买</a:t>
+              <a:t>买零食“更多的是”尝鲜，口感不差“就会继续再买”</a:t>
             </a:r>
             <a:endParaRPr lang="en-US" sz="1300" dirty="0"/>
           </a:p>
@@ -7826,7 +7826,7 @@
                   <a:schemeClr val="accent3"/>
                 </a:solidFill>
               </a:rPr>
-              <a:t>企业导师 丁其磊老师；量贩渠道是“买手”，品牌话语权弱</a:t>
+              <a:t>企业导师 丁其磊老师；渠道是“买手”，会到工厂来选货</a:t>
             </a:r>
             <a:endParaRPr lang="en-US" sz="1300" dirty="0"/>
           </a:p>

</xml_diff>

<commit_message>
Final speech script; sync slide notes with it
Co-Authored-By: Claude Opus 5.5 <noreply@anthropic.com>
Claude-Session: https://claude.ai/code/session_01CU6W6huYbDSXyzWhJKPgvt
</commit_message>
<xml_diff>
--- a/ppt/v4/制作1_封面目录分隔页_P2-P5_P14-P15.pptx
+++ b/ppt/v4/制作1_封面目录分隔页_P2-P5_P14-P15.pptx
@@ -117,13 +117,13 @@
   <p:extLst>
     <p:ext uri="{521415D9-36F7-43E2-AB2F-B90AF26B5E84}">
       <p14:sectionLst xmlns:p14="http://schemas.microsoft.com/office/powerpoint/2010/main">
-        <p14:section name="开场" id="{02a86ff6-066e-75e8-eedc-933373fce55e}">
+        <p14:section name="开场" id="{19075844-949f-7204-f7bb-b8d2a3453a92}">
           <p14:sldIdLst>
             <p14:sldId id="256"/>
             <p14:sldId id="257"/>
           </p14:sldIdLst>
         </p14:section>
-        <p14:section name="背景与问题" id="{ca3003b1-bed8-e8ac-b6b5-7e336a387d1a}">
+        <p14:section name="背景与问题" id="{e4c30aab-7252-62dc-40cf-5f6bcc7d8d32}">
           <p14:sldIdLst>
             <p14:sldId id="258"/>
             <p14:sldId id="259"/>
@@ -132,13 +132,13 @@
             <p14:sldId id="262"/>
           </p14:sldIdLst>
         </p14:section>
-        <p14:section name="分隔页（插到方案、执行部分前）" id="{1b25d176-5d95-6a12-e779-97b631607396}">
+        <p14:section name="分隔页（插到方案、执行部分前）" id="{d8ddcc31-9e91-9c40-d207-d4991109a96e}">
           <p14:sldIdLst>
             <p14:sldId id="263"/>
             <p14:sldId id="264"/>
           </p14:sldIdLst>
         </p14:section>
-        <p14:section name="总结与封底" id="{28b5d3df-26ce-eca2-e0c4-8156cbcbe933}">
+        <p14:section name="总结与封底" id="{a2b58ad2-1c09-b182-e274-b4b60270da02}">
           <p14:sldIdLst>
             <p14:sldId id="265"/>
             <p14:sldId id="266"/>
@@ -548,7 +548,8 @@
           <a:p>
             <a:r>
               <a:rPr lang="en-US" dirty="0"/>
-              <a:t>【A｜约 10 秒】老师好，我们组要回答的核心问题是：如何让 18–25 岁年轻人在量贩零食店第一次尝鲜美枣王，并通过首购体验带动复购？</a:t>
+              <a:t>【A｜约 14 秒】老师好，我们组要回答的核心问题是：如何让 18–25 岁年轻人在量贩零食店第一次尝鲜美枣王，并通过首购体验带动复购？
+提示：核心问题全组统一，一个字都不要改。说完停一拍再翻页。</a:t>
             </a:r>
             <a:endParaRPr lang="en-US" dirty="0"/>
           </a:p>
@@ -636,7 +637,8 @@
           <a:p>
             <a:r>
               <a:rPr lang="en-US" dirty="0"/>
-              <a:t>【C｜约 20 秒】回到我们的核心问题。问题是首购没有变成复购；方案是一条种草、尝鲜、验证、复购的闭环；落地从一所学校开始，4 周、约 2600 元，跑通就能复制。我们希望从一所学校跑通，变成美枣王在全国量贩渠道的年轻化增长模式。</a:t>
+              <a:t>【C｜约 18 秒】回到我们的核心问题。问题是首购没有变成复购；方案是种草、尝鲜、验证、复购的闭环；落地从一所学校开始，4 周、约 2600 元，跑通就能复制。从一所学校，到全国量贩渠道。
+提示：2600 元以制作 4 的 P12 最终数字为准，改了这里也要改。</a:t>
             </a:r>
             <a:endParaRPr lang="en-US" dirty="0"/>
           </a:p>
@@ -724,7 +726,8 @@
           <a:p>
             <a:r>
               <a:rPr lang="en-US" dirty="0"/>
-              <a:t>【C｜约 5 秒】让年轻人第一口就爱上，第二包自然会来。谢谢老师！</a:t>
+              <a:t>【C｜约 5 秒】让年轻人第一口就爱上，第二包自然会来。谢谢老师！
+提示：说完停在这页，等老师提问。</a:t>
             </a:r>
             <a:endParaRPr lang="en-US" dirty="0"/>
           </a:p>
@@ -812,7 +815,8 @@
           <a:p>
             <a:r>
               <a:rPr lang="en-US" dirty="0"/>
-              <a:t>【A｜约 5 秒，带过】我们分三部分讲：先找问题，再给方案，最后讲怎么落地。</a:t>
+              <a:t>【A｜约 6 秒】我们分三部分讲：先找问题，再给方案，最后讲怎么落地。
+提示：带过即可，不要逐条念。</a:t>
             </a:r>
             <a:endParaRPr lang="en-US" dirty="0"/>
           </a:p>
@@ -900,7 +904,8 @@
           <a:p>
             <a:r>
               <a:rPr lang="en-US" dirty="0"/>
-              <a:t/>
+              <a:t>【A｜约 2 秒】先看背景与问题。
+提示：一句话即翻页。</a:t>
             </a:r>
             <a:endParaRPr lang="en-US" dirty="0"/>
           </a:p>
@@ -988,7 +993,8 @@
           <a:p>
             <a:r>
               <a:rPr lang="en-US" dirty="0"/>
-              <a:t>【A｜约 25 秒】先看两个事实：行业龙头 2025 年底门店已经超过 2 万家，头部两家合计占了七成半的份额——品牌要找年轻人，就得进量贩店。再看人：我们访谈的 15 个同龄人里，9 个吃完会去查配料或含糖量；2027 年起，营养标签新国标还要求把“糖”强制标出来。年轻人尝鲜大于品牌，也越来越在意健康。机会很大，但卖法要变。</a:t>
+              <a:t>【A｜约 23 秒】先看两个事实：行业龙头门店超过 2 万家，头部两家占了 七成半 份额——品牌想找年轻人，就得进量贩店。再看人：15 个同龄人里，9 个吃完会查配料或含糖量。年轻人尝鲜大于品牌，也越来越在意健康——机会很大，但卖法要变。
+提示：讲到 75.5% 和 9/15 两个大数字时各停半拍。“糖必标”新国标在页面上，不用念；老师问起再说：2027 年 3 月起包装要强制标示糖。数字出处在页面右下角：龙头业绩公告、万辰集团招股书、GB 28050-2025。</a:t>
             </a:r>
             <a:endParaRPr lang="en-US" dirty="0"/>
           </a:p>
@@ -1076,7 +1082,8 @@
           <a:p>
             <a:r>
               <a:rPr lang="en-US" dirty="0"/>
-              <a:t>【A｜约 30 秒】用自己的经历讲：我上周刷小红书看到一款新零食，第二天就去了学校门口的零食店，先买一小包；吃完第一件事是翻过来看配料表。这就是年轻人买零食的四步：种草、尝鲜、验证、复购。我们访谈的 15 个人里，10 个最近一次是在小红书被种草，9 个吃完会查配料或含糖量。而美枣王在每一步都掉队：线上没人种草，店里不显眼，枣像养生品，包装没回答健康问题，也没有再买的理由。</a:t>
+              <a:t>【A｜约 28 秒】【换成你自己的真实经历】上周我刷小红书看到一款新零食，第二天就去校门口买了一小包，吃完先翻配料表。这就是年轻人买零食的四步：种草、尝鲜、验证、复购。而美枣王步步掉队：线上没人种草，店里找不到，枣像养生品，包装不回答健康问题，也没有再买的理由。
+提示：第一句必须是演讲人自己真实发生过的事，老师很可能追问。讲四步时手从左往右指着路径图走。</a:t>
             </a:r>
             <a:endParaRPr lang="en-US" dirty="0"/>
           </a:p>
@@ -1164,7 +1171,8 @@
           <a:p>
             <a:r>
               <a:rPr lang="en-US" dirty="0"/>
-              <a:t>【A｜约 35 秒，全篇转折点，语速放慢】所以我们把问题重新定义为：如何让 18–25 岁年轻人在量贩零食店第一次尝鲜美枣王，并通过首购体验带动复购？年轻人本来就爱尝鲜，只追求第一次买意义不大。本质有两条：第一，线上种草、线下货架、产品体验三段是断开的，被种草了找不到店，买到了不知道健不健康；第二，品牌、门店、内容创作者各做各的，没有一起创造第一次尝鲜的体验。丁其磊老师说，零食消费更多是尝鲜，尝了不错才会继续买。</a:t>
+              <a:t>【A｜约 33 秒】所以我们把问题重新定义为——如何让 18–25 岁年轻人在量贩零食店第一次尝鲜美枣王，并通过首购体验带动复购？只追求第一次买意义不大，要在第一次体验里就埋好再买的理由。本质有两条：一是线上种草、线下货架、产品体验三段断开；二是品牌、门店、内容创作者各做各的，没有一起创造第一次尝鲜。
+提示：全篇转折点，语速放慢，核心问题原句念出。时间富余可以加一句：丁其磊老师也说，买零食更多的是尝鲜，口感不差就会继续再买。</a:t>
             </a:r>
             <a:endParaRPr lang="en-US" dirty="0"/>
           </a:p>
@@ -1252,7 +1260,8 @@
           <a:p>
             <a:r>
               <a:rPr lang="en-US" dirty="0"/>
-              <a:t>【A｜约 20 秒，带过】这些判断来自四种方法：访谈了 15 位同龄人，用 AI 分析小红书笔记再人工复核，做了 1 次企业导师访谈，走访了学校周边门店。问卷留到第二步开始前做验证。问题找到了，下面看我们设计的闭环。</a:t>
+              <a:t>【A｜约 15 秒】这些判断来自四种方法：同龄人访谈、小红书笔记分析、企业导师访谈和门店走访；问卷留到第二步前做验证。问题找到了，下面看我们设计的闭环。
+提示：最后一句是交接词，说完把翻页笔交给 B。</a:t>
             </a:r>
             <a:endParaRPr lang="en-US" dirty="0"/>
           </a:p>
@@ -1340,7 +1349,8 @@
           <a:p>
             <a:r>
               <a:rPr lang="en-US" dirty="0"/>
-              <a:t>插在方案总览（原 P6）之前。</a:t>
+              <a:t>【B｜约 3 秒】下面看我们的解决方案。
+提示：B 接过翻页笔后的第一句，一句话即翻页。</a:t>
             </a:r>
             <a:endParaRPr lang="en-US" dirty="0"/>
           </a:p>
@@ -1428,7 +1438,8 @@
           <a:p>
             <a:r>
               <a:rPr lang="en-US" dirty="0"/>
-              <a:t>插在“分三步走”（原 P11）之前。</a:t>
+              <a:t>【C｜约 4 秒】方案讲完了，接下来讲怎么一步步落地。
+提示：C 接过翻页笔后的第一句，一句话即翻页。</a:t>
             </a:r>
             <a:endParaRPr lang="en-US" dirty="0"/>
           </a:p>

</xml_diff>